<commit_message>
Upgrade PDF with tech backgrounds, SVG logo, tri-currency pricing; update PPTX logo
PDF (VelaSync_Advisor_QuickRef.pdf):
- SVG sailboat logo on both pages matching brand identity
- Tech background: hex grid, circuit traces, node pads, ambient glow, binary strips
- Tri-currency pricing: £/$/€ on setup and monthly for both packages

PPTX (VelaSync_Sales_Process_WithLogo.pptx):
- Replaced text-only top-right logo on slides 2-11 with full branded logo
  (dark pill, teal circle, sailboat icon, VELA SYNC wordmark + URL)

https://claude.ai/code/session_01YTDwVHBFFg59j1sozRnPrw
</commit_message>
<xml_diff>
--- a/VelaSync_Sales_Process_WithLogo.pptx
+++ b/VelaSync_Sales_Process_WithLogo.pptx
@@ -7905,23 +7905,61 @@
       </p:sp>
       <p:sp>
         <p:nvSpPr>
-          <p:cNvPr id="86" name="Rectangle 85"/>
+          <p:cNvPr id="88" name="TextBox 87"/>
+          <p:cNvSpPr txBox="1"/>
+          <p:nvPr/>
+        </p:nvSpPr>
+        <p:spPr>
+          <a:xfrm>
+            <a:off x="10360152" y="320040"/>
+            <a:ext cx="1005840" cy="274320"/>
+          </a:xfrm>
+          <a:prstGeom prst="rect">
+            <a:avLst/>
+          </a:prstGeom>
+          <a:noFill/>
+        </p:spPr>
+        <p:txBody>
+          <a:bodyPr wrap="none">
+            <a:spAutoFit/>
+          </a:bodyPr>
+          <a:lstStyle/>
+          <a:p>
+            <a:pPr algn="r"/>
+            <a:r>
+              <a:rPr b="1" sz="800">
+                <a:solidFill>
+                  <a:srgbClr val="EEF7F7"/>
+                </a:solidFill>
+              </a:rPr>
+              <a:t>VELA SYNC</a:t>
+            </a:r>
+          </a:p>
+        </p:txBody>
+      </p:sp>
+      <p:sp>
+        <p:nvSpPr>
+          <p:cNvPr id="89" name="logo_bg"/>
           <p:cNvSpPr/>
           <p:nvPr/>
         </p:nvSpPr>
         <p:spPr>
           <a:xfrm>
-            <a:off x="11411712" y="228600"/>
-            <a:ext cx="457200" cy="457200"/>
-          </a:xfrm>
-          <a:prstGeom prst="rect">
-            <a:avLst/>
-          </a:prstGeom>
-          <a:solidFill>
-            <a:srgbClr val="2B8E8E"/>
-          </a:solidFill>
-          <a:ln>
-            <a:noFill/>
+            <a:off x="10378440" y="164592"/>
+            <a:ext cx="1600200" cy="438912"/>
+          </a:xfrm>
+          <a:prstGeom prst="roundRect">
+            <a:avLst>
+              <a:gd name="adj" fmla="val 25000"/>
+            </a:avLst>
+          </a:prstGeom>
+          <a:solidFill>
+            <a:srgbClr val="0F1A1A"/>
+          </a:solidFill>
+          <a:ln w="7620">
+            <a:solidFill>
+              <a:srgbClr val="268282"/>
+            </a:solidFill>
           </a:ln>
         </p:spPr>
         <p:style>
@@ -7948,14 +7986,57 @@
       </p:sp>
       <p:sp>
         <p:nvSpPr>
-          <p:cNvPr id="87" name="TextBox 86"/>
-          <p:cNvSpPr txBox="1"/>
-          <p:nvPr/>
-        </p:nvSpPr>
-        <p:spPr>
-          <a:xfrm>
-            <a:off x="11411712" y="228600"/>
-            <a:ext cx="457200" cy="457200"/>
+          <p:cNvPr id="90" name="logo_circle"/>
+          <p:cNvSpPr/>
+          <p:nvPr/>
+        </p:nvSpPr>
+        <p:spPr>
+          <a:xfrm>
+            <a:off x="10397093" y="197510"/>
+            <a:ext cx="373075" cy="373075"/>
+          </a:xfrm>
+          <a:prstGeom prst="ellipse">
+            <a:avLst/>
+          </a:prstGeom>
+          <a:solidFill>
+            <a:srgbClr val="268282"/>
+          </a:solidFill>
+          <a:ln>
+            <a:noFill/>
+          </a:ln>
+        </p:spPr>
+        <p:style>
+          <a:lnRef idx="1">
+            <a:schemeClr val="accent1"/>
+          </a:lnRef>
+          <a:fillRef idx="3">
+            <a:schemeClr val="accent1"/>
+          </a:fillRef>
+          <a:effectRef idx="2">
+            <a:schemeClr val="accent1"/>
+          </a:effectRef>
+          <a:fontRef idx="minor">
+            <a:schemeClr val="lt1"/>
+          </a:fontRef>
+        </p:style>
+        <p:txBody>
+          <a:bodyPr rtlCol="0" anchor="ctr"/>
+          <a:lstStyle/>
+          <a:p>
+            <a:pPr algn="ctr"/>
+          </a:p>
+        </p:txBody>
+      </p:sp>
+      <p:sp>
+        <p:nvSpPr>
+          <p:cNvPr id="91" name="logo_text"/>
+          <p:cNvSpPr txBox="1"/>
+          <p:nvPr/>
+        </p:nvSpPr>
+        <p:spPr>
+          <a:xfrm>
+            <a:off x="10843686" y="201168"/>
+            <a:ext cx="1134953" cy="241401"/>
           </a:xfrm>
           <a:prstGeom prst="rect">
             <a:avLst/>
@@ -7968,48 +8049,84 @@
           </a:bodyPr>
           <a:lstStyle/>
           <a:p>
-            <a:pPr algn="ctr"/>
-            <a:r>
-              <a:rPr b="1" sz="1400">
+            <a:pPr algn="l"/>
+            <a:r>
+              <a:rPr sz="750" b="1">
+                <a:solidFill>
+                  <a:srgbClr val="EEF7F7"/>
+                </a:solidFill>
+                <a:latin typeface="Helvetica Neue"/>
+              </a:rPr>
+              <a:t>VELA SYNC</a:t>
+            </a:r>
+          </a:p>
+        </p:txBody>
+      </p:sp>
+      <p:sp>
+        <p:nvSpPr>
+          <p:cNvPr id="92" name="logo_subtext"/>
+          <p:cNvSpPr txBox="1"/>
+          <p:nvPr/>
+        </p:nvSpPr>
+        <p:spPr>
+          <a:xfrm>
+            <a:off x="10843686" y="405993"/>
+            <a:ext cx="1134953" cy="175564"/>
+          </a:xfrm>
+          <a:prstGeom prst="rect">
+            <a:avLst/>
+          </a:prstGeom>
+          <a:noFill/>
+        </p:spPr>
+        <p:txBody>
+          <a:bodyPr wrap="none">
+            <a:spAutoFit/>
+          </a:bodyPr>
+          <a:lstStyle/>
+          <a:p>
+            <a:pPr algn="l"/>
+            <a:r>
+              <a:rPr sz="500">
+                <a:solidFill>
+                  <a:srgbClr val="3AAEAE"/>
+                </a:solidFill>
+                <a:latin typeface="Helvetica Neue"/>
+              </a:rPr>
+              <a:t>velasync.co.uk</a:t>
+            </a:r>
+          </a:p>
+        </p:txBody>
+      </p:sp>
+      <p:sp>
+        <p:nvSpPr>
+          <p:cNvPr id="94" name="logo_icon"/>
+          <p:cNvSpPr txBox="1"/>
+          <p:nvPr/>
+        </p:nvSpPr>
+        <p:spPr>
+          <a:xfrm>
+            <a:off x="10441862" y="216164"/>
+            <a:ext cx="283537" cy="298460"/>
+          </a:xfrm>
+          <a:prstGeom prst="rect">
+            <a:avLst/>
+          </a:prstGeom>
+          <a:noFill/>
+        </p:spPr>
+        <p:txBody>
+          <a:bodyPr wrap="none">
+            <a:spAutoFit/>
+          </a:bodyPr>
+          <a:lstStyle/>
+          <a:p>
+            <a:pPr algn="ctr"/>
+            <a:r>
+              <a:rPr sz="1527">
                 <a:solidFill>
                   <a:srgbClr val="FFFFFF"/>
                 </a:solidFill>
               </a:rPr>
-              <a:t>VS</a:t>
-            </a:r>
-          </a:p>
-        </p:txBody>
-      </p:sp>
-      <p:sp>
-        <p:nvSpPr>
-          <p:cNvPr id="88" name="TextBox 87"/>
-          <p:cNvSpPr txBox="1"/>
-          <p:nvPr/>
-        </p:nvSpPr>
-        <p:spPr>
-          <a:xfrm>
-            <a:off x="10360152" y="320040"/>
-            <a:ext cx="1005840" cy="274320"/>
-          </a:xfrm>
-          <a:prstGeom prst="rect">
-            <a:avLst/>
-          </a:prstGeom>
-          <a:noFill/>
-        </p:spPr>
-        <p:txBody>
-          <a:bodyPr wrap="none">
-            <a:spAutoFit/>
-          </a:bodyPr>
-          <a:lstStyle/>
-          <a:p>
-            <a:pPr algn="r"/>
-            <a:r>
-              <a:rPr b="1" sz="800">
-                <a:solidFill>
-                  <a:srgbClr val="EEF7F7"/>
-                </a:solidFill>
-              </a:rPr>
-              <a:t>VELA SYNC</a:t>
+              <a:t>⛵</a:t>
             </a:r>
           </a:p>
         </p:txBody>
@@ -9283,6 +9400,200 @@
           </a:p>
         </p:txBody>
       </p:sp>
+      <p:sp>
+        <p:nvSpPr>
+          <p:cNvPr id="34" name="logo_bg"/>
+          <p:cNvSpPr/>
+          <p:nvPr/>
+        </p:nvSpPr>
+        <p:spPr>
+          <a:xfrm>
+            <a:off x="10378440" y="164592"/>
+            <a:ext cx="1600200" cy="438912"/>
+          </a:xfrm>
+          <a:prstGeom prst="roundRect">
+            <a:avLst>
+              <a:gd name="adj" fmla="val 25000"/>
+            </a:avLst>
+          </a:prstGeom>
+          <a:solidFill>
+            <a:srgbClr val="0F1A1A"/>
+          </a:solidFill>
+          <a:ln w="7620">
+            <a:solidFill>
+              <a:srgbClr val="268282"/>
+            </a:solidFill>
+          </a:ln>
+        </p:spPr>
+        <p:style>
+          <a:lnRef idx="1">
+            <a:schemeClr val="accent1"/>
+          </a:lnRef>
+          <a:fillRef idx="3">
+            <a:schemeClr val="accent1"/>
+          </a:fillRef>
+          <a:effectRef idx="2">
+            <a:schemeClr val="accent1"/>
+          </a:effectRef>
+          <a:fontRef idx="minor">
+            <a:schemeClr val="lt1"/>
+          </a:fontRef>
+        </p:style>
+        <p:txBody>
+          <a:bodyPr rtlCol="0" anchor="ctr"/>
+          <a:lstStyle/>
+          <a:p>
+            <a:pPr algn="ctr"/>
+          </a:p>
+        </p:txBody>
+      </p:sp>
+      <p:sp>
+        <p:nvSpPr>
+          <p:cNvPr id="35" name="logo_circle"/>
+          <p:cNvSpPr/>
+          <p:nvPr/>
+        </p:nvSpPr>
+        <p:spPr>
+          <a:xfrm>
+            <a:off x="10397093" y="197510"/>
+            <a:ext cx="373075" cy="373075"/>
+          </a:xfrm>
+          <a:prstGeom prst="ellipse">
+            <a:avLst/>
+          </a:prstGeom>
+          <a:solidFill>
+            <a:srgbClr val="268282"/>
+          </a:solidFill>
+          <a:ln>
+            <a:noFill/>
+          </a:ln>
+        </p:spPr>
+        <p:style>
+          <a:lnRef idx="1">
+            <a:schemeClr val="accent1"/>
+          </a:lnRef>
+          <a:fillRef idx="3">
+            <a:schemeClr val="accent1"/>
+          </a:fillRef>
+          <a:effectRef idx="2">
+            <a:schemeClr val="accent1"/>
+          </a:effectRef>
+          <a:fontRef idx="minor">
+            <a:schemeClr val="lt1"/>
+          </a:fontRef>
+        </p:style>
+        <p:txBody>
+          <a:bodyPr rtlCol="0" anchor="ctr"/>
+          <a:lstStyle/>
+          <a:p>
+            <a:pPr algn="ctr"/>
+          </a:p>
+        </p:txBody>
+      </p:sp>
+      <p:sp>
+        <p:nvSpPr>
+          <p:cNvPr id="36" name="logo_text"/>
+          <p:cNvSpPr txBox="1"/>
+          <p:nvPr/>
+        </p:nvSpPr>
+        <p:spPr>
+          <a:xfrm>
+            <a:off x="10843686" y="201168"/>
+            <a:ext cx="1134953" cy="241401"/>
+          </a:xfrm>
+          <a:prstGeom prst="rect">
+            <a:avLst/>
+          </a:prstGeom>
+          <a:noFill/>
+        </p:spPr>
+        <p:txBody>
+          <a:bodyPr wrap="none">
+            <a:spAutoFit/>
+          </a:bodyPr>
+          <a:lstStyle/>
+          <a:p>
+            <a:pPr algn="l"/>
+            <a:r>
+              <a:rPr sz="750" b="1">
+                <a:solidFill>
+                  <a:srgbClr val="EEF7F7"/>
+                </a:solidFill>
+                <a:latin typeface="Helvetica Neue"/>
+              </a:rPr>
+              <a:t>VELA SYNC</a:t>
+            </a:r>
+          </a:p>
+        </p:txBody>
+      </p:sp>
+      <p:sp>
+        <p:nvSpPr>
+          <p:cNvPr id="37" name="logo_subtext"/>
+          <p:cNvSpPr txBox="1"/>
+          <p:nvPr/>
+        </p:nvSpPr>
+        <p:spPr>
+          <a:xfrm>
+            <a:off x="10843686" y="405993"/>
+            <a:ext cx="1134953" cy="175564"/>
+          </a:xfrm>
+          <a:prstGeom prst="rect">
+            <a:avLst/>
+          </a:prstGeom>
+          <a:noFill/>
+        </p:spPr>
+        <p:txBody>
+          <a:bodyPr wrap="none">
+            <a:spAutoFit/>
+          </a:bodyPr>
+          <a:lstStyle/>
+          <a:p>
+            <a:pPr algn="l"/>
+            <a:r>
+              <a:rPr sz="500">
+                <a:solidFill>
+                  <a:srgbClr val="3AAEAE"/>
+                </a:solidFill>
+                <a:latin typeface="Helvetica Neue"/>
+              </a:rPr>
+              <a:t>velasync.co.uk</a:t>
+            </a:r>
+          </a:p>
+        </p:txBody>
+      </p:sp>
+      <p:sp>
+        <p:nvSpPr>
+          <p:cNvPr id="39" name="logo_icon"/>
+          <p:cNvSpPr txBox="1"/>
+          <p:nvPr/>
+        </p:nvSpPr>
+        <p:spPr>
+          <a:xfrm>
+            <a:off x="10441862" y="216164"/>
+            <a:ext cx="283537" cy="298460"/>
+          </a:xfrm>
+          <a:prstGeom prst="rect">
+            <a:avLst/>
+          </a:prstGeom>
+          <a:noFill/>
+        </p:spPr>
+        <p:txBody>
+          <a:bodyPr wrap="none">
+            <a:spAutoFit/>
+          </a:bodyPr>
+          <a:lstStyle/>
+          <a:p>
+            <a:pPr algn="ctr"/>
+            <a:r>
+              <a:rPr sz="1527">
+                <a:solidFill>
+                  <a:srgbClr val="FFFFFF"/>
+                </a:solidFill>
+              </a:rPr>
+              <a:t>⛵</a:t>
+            </a:r>
+          </a:p>
+        </p:txBody>
+      </p:sp>
     </p:spTree>
   </p:cSld>
   <p:clrMapOvr>
@@ -12197,23 +12508,61 @@
       </p:sp>
       <p:sp>
         <p:nvSpPr>
-          <p:cNvPr id="79" name="Rectangle 78"/>
+          <p:cNvPr id="81" name="TextBox 80"/>
+          <p:cNvSpPr txBox="1"/>
+          <p:nvPr/>
+        </p:nvSpPr>
+        <p:spPr>
+          <a:xfrm>
+            <a:off x="10360152" y="320040"/>
+            <a:ext cx="1005840" cy="274320"/>
+          </a:xfrm>
+          <a:prstGeom prst="rect">
+            <a:avLst/>
+          </a:prstGeom>
+          <a:noFill/>
+        </p:spPr>
+        <p:txBody>
+          <a:bodyPr wrap="none">
+            <a:spAutoFit/>
+          </a:bodyPr>
+          <a:lstStyle/>
+          <a:p>
+            <a:pPr algn="r"/>
+            <a:r>
+              <a:rPr b="1" sz="800">
+                <a:solidFill>
+                  <a:srgbClr val="EEF7F7"/>
+                </a:solidFill>
+              </a:rPr>
+              <a:t>VELA SYNC</a:t>
+            </a:r>
+          </a:p>
+        </p:txBody>
+      </p:sp>
+      <p:sp>
+        <p:nvSpPr>
+          <p:cNvPr id="82" name="logo_bg"/>
           <p:cNvSpPr/>
           <p:nvPr/>
         </p:nvSpPr>
         <p:spPr>
           <a:xfrm>
-            <a:off x="11411712" y="228600"/>
-            <a:ext cx="457200" cy="457200"/>
-          </a:xfrm>
-          <a:prstGeom prst="rect">
-            <a:avLst/>
-          </a:prstGeom>
-          <a:solidFill>
-            <a:srgbClr val="2B8E8E"/>
-          </a:solidFill>
-          <a:ln>
-            <a:noFill/>
+            <a:off x="10378440" y="164592"/>
+            <a:ext cx="1600200" cy="438912"/>
+          </a:xfrm>
+          <a:prstGeom prst="roundRect">
+            <a:avLst>
+              <a:gd name="adj" fmla="val 25000"/>
+            </a:avLst>
+          </a:prstGeom>
+          <a:solidFill>
+            <a:srgbClr val="0F1A1A"/>
+          </a:solidFill>
+          <a:ln w="7620">
+            <a:solidFill>
+              <a:srgbClr val="268282"/>
+            </a:solidFill>
           </a:ln>
         </p:spPr>
         <p:style>
@@ -12240,14 +12589,57 @@
       </p:sp>
       <p:sp>
         <p:nvSpPr>
-          <p:cNvPr id="80" name="TextBox 79"/>
-          <p:cNvSpPr txBox="1"/>
-          <p:nvPr/>
-        </p:nvSpPr>
-        <p:spPr>
-          <a:xfrm>
-            <a:off x="11411712" y="228600"/>
-            <a:ext cx="457200" cy="457200"/>
+          <p:cNvPr id="83" name="logo_circle"/>
+          <p:cNvSpPr/>
+          <p:nvPr/>
+        </p:nvSpPr>
+        <p:spPr>
+          <a:xfrm>
+            <a:off x="10397093" y="197510"/>
+            <a:ext cx="373075" cy="373075"/>
+          </a:xfrm>
+          <a:prstGeom prst="ellipse">
+            <a:avLst/>
+          </a:prstGeom>
+          <a:solidFill>
+            <a:srgbClr val="268282"/>
+          </a:solidFill>
+          <a:ln>
+            <a:noFill/>
+          </a:ln>
+        </p:spPr>
+        <p:style>
+          <a:lnRef idx="1">
+            <a:schemeClr val="accent1"/>
+          </a:lnRef>
+          <a:fillRef idx="3">
+            <a:schemeClr val="accent1"/>
+          </a:fillRef>
+          <a:effectRef idx="2">
+            <a:schemeClr val="accent1"/>
+          </a:effectRef>
+          <a:fontRef idx="minor">
+            <a:schemeClr val="lt1"/>
+          </a:fontRef>
+        </p:style>
+        <p:txBody>
+          <a:bodyPr rtlCol="0" anchor="ctr"/>
+          <a:lstStyle/>
+          <a:p>
+            <a:pPr algn="ctr"/>
+          </a:p>
+        </p:txBody>
+      </p:sp>
+      <p:sp>
+        <p:nvSpPr>
+          <p:cNvPr id="84" name="logo_text"/>
+          <p:cNvSpPr txBox="1"/>
+          <p:nvPr/>
+        </p:nvSpPr>
+        <p:spPr>
+          <a:xfrm>
+            <a:off x="10843686" y="201168"/>
+            <a:ext cx="1134953" cy="241401"/>
           </a:xfrm>
           <a:prstGeom prst="rect">
             <a:avLst/>
@@ -12260,48 +12652,84 @@
           </a:bodyPr>
           <a:lstStyle/>
           <a:p>
-            <a:pPr algn="ctr"/>
-            <a:r>
-              <a:rPr b="1" sz="1400">
+            <a:pPr algn="l"/>
+            <a:r>
+              <a:rPr sz="750" b="1">
+                <a:solidFill>
+                  <a:srgbClr val="EEF7F7"/>
+                </a:solidFill>
+                <a:latin typeface="Helvetica Neue"/>
+              </a:rPr>
+              <a:t>VELA SYNC</a:t>
+            </a:r>
+          </a:p>
+        </p:txBody>
+      </p:sp>
+      <p:sp>
+        <p:nvSpPr>
+          <p:cNvPr id="85" name="logo_subtext"/>
+          <p:cNvSpPr txBox="1"/>
+          <p:nvPr/>
+        </p:nvSpPr>
+        <p:spPr>
+          <a:xfrm>
+            <a:off x="10843686" y="405993"/>
+            <a:ext cx="1134953" cy="175564"/>
+          </a:xfrm>
+          <a:prstGeom prst="rect">
+            <a:avLst/>
+          </a:prstGeom>
+          <a:noFill/>
+        </p:spPr>
+        <p:txBody>
+          <a:bodyPr wrap="none">
+            <a:spAutoFit/>
+          </a:bodyPr>
+          <a:lstStyle/>
+          <a:p>
+            <a:pPr algn="l"/>
+            <a:r>
+              <a:rPr sz="500">
+                <a:solidFill>
+                  <a:srgbClr val="3AAEAE"/>
+                </a:solidFill>
+                <a:latin typeface="Helvetica Neue"/>
+              </a:rPr>
+              <a:t>velasync.co.uk</a:t>
+            </a:r>
+          </a:p>
+        </p:txBody>
+      </p:sp>
+      <p:sp>
+        <p:nvSpPr>
+          <p:cNvPr id="87" name="logo_icon"/>
+          <p:cNvSpPr txBox="1"/>
+          <p:nvPr/>
+        </p:nvSpPr>
+        <p:spPr>
+          <a:xfrm>
+            <a:off x="10441862" y="216164"/>
+            <a:ext cx="283537" cy="298460"/>
+          </a:xfrm>
+          <a:prstGeom prst="rect">
+            <a:avLst/>
+          </a:prstGeom>
+          <a:noFill/>
+        </p:spPr>
+        <p:txBody>
+          <a:bodyPr wrap="none">
+            <a:spAutoFit/>
+          </a:bodyPr>
+          <a:lstStyle/>
+          <a:p>
+            <a:pPr algn="ctr"/>
+            <a:r>
+              <a:rPr sz="1527">
                 <a:solidFill>
                   <a:srgbClr val="FFFFFF"/>
                 </a:solidFill>
               </a:rPr>
-              <a:t>VS</a:t>
-            </a:r>
-          </a:p>
-        </p:txBody>
-      </p:sp>
-      <p:sp>
-        <p:nvSpPr>
-          <p:cNvPr id="81" name="TextBox 80"/>
-          <p:cNvSpPr txBox="1"/>
-          <p:nvPr/>
-        </p:nvSpPr>
-        <p:spPr>
-          <a:xfrm>
-            <a:off x="10360152" y="320040"/>
-            <a:ext cx="1005840" cy="274320"/>
-          </a:xfrm>
-          <a:prstGeom prst="rect">
-            <a:avLst/>
-          </a:prstGeom>
-          <a:noFill/>
-        </p:spPr>
-        <p:txBody>
-          <a:bodyPr wrap="none">
-            <a:spAutoFit/>
-          </a:bodyPr>
-          <a:lstStyle/>
-          <a:p>
-            <a:pPr algn="r"/>
-            <a:r>
-              <a:rPr b="1" sz="800">
-                <a:solidFill>
-                  <a:srgbClr val="EEF7F7"/>
-                </a:solidFill>
-              </a:rPr>
-              <a:t>VELA SYNC</a:t>
+              <a:t>⛵</a:t>
             </a:r>
           </a:p>
         </p:txBody>
@@ -14347,23 +14775,61 @@
       </p:sp>
       <p:sp>
         <p:nvSpPr>
-          <p:cNvPr id="55" name="Rectangle 54"/>
+          <p:cNvPr id="57" name="TextBox 56"/>
+          <p:cNvSpPr txBox="1"/>
+          <p:nvPr/>
+        </p:nvSpPr>
+        <p:spPr>
+          <a:xfrm>
+            <a:off x="10360152" y="320040"/>
+            <a:ext cx="1005840" cy="274320"/>
+          </a:xfrm>
+          <a:prstGeom prst="rect">
+            <a:avLst/>
+          </a:prstGeom>
+          <a:noFill/>
+        </p:spPr>
+        <p:txBody>
+          <a:bodyPr wrap="none">
+            <a:spAutoFit/>
+          </a:bodyPr>
+          <a:lstStyle/>
+          <a:p>
+            <a:pPr algn="r"/>
+            <a:r>
+              <a:rPr b="1" sz="800">
+                <a:solidFill>
+                  <a:srgbClr val="EEF7F7"/>
+                </a:solidFill>
+              </a:rPr>
+              <a:t>VELA SYNC</a:t>
+            </a:r>
+          </a:p>
+        </p:txBody>
+      </p:sp>
+      <p:sp>
+        <p:nvSpPr>
+          <p:cNvPr id="58" name="logo_bg"/>
           <p:cNvSpPr/>
           <p:nvPr/>
         </p:nvSpPr>
         <p:spPr>
           <a:xfrm>
-            <a:off x="11411712" y="228600"/>
-            <a:ext cx="457200" cy="457200"/>
-          </a:xfrm>
-          <a:prstGeom prst="rect">
-            <a:avLst/>
-          </a:prstGeom>
-          <a:solidFill>
-            <a:srgbClr val="2B8E8E"/>
-          </a:solidFill>
-          <a:ln>
-            <a:noFill/>
+            <a:off x="10378440" y="164592"/>
+            <a:ext cx="1600200" cy="438912"/>
+          </a:xfrm>
+          <a:prstGeom prst="roundRect">
+            <a:avLst>
+              <a:gd name="adj" fmla="val 25000"/>
+            </a:avLst>
+          </a:prstGeom>
+          <a:solidFill>
+            <a:srgbClr val="0F1A1A"/>
+          </a:solidFill>
+          <a:ln w="7620">
+            <a:solidFill>
+              <a:srgbClr val="268282"/>
+            </a:solidFill>
           </a:ln>
         </p:spPr>
         <p:style>
@@ -14390,14 +14856,57 @@
       </p:sp>
       <p:sp>
         <p:nvSpPr>
-          <p:cNvPr id="56" name="TextBox 55"/>
-          <p:cNvSpPr txBox="1"/>
-          <p:nvPr/>
-        </p:nvSpPr>
-        <p:spPr>
-          <a:xfrm>
-            <a:off x="11411712" y="228600"/>
-            <a:ext cx="457200" cy="457200"/>
+          <p:cNvPr id="59" name="logo_circle"/>
+          <p:cNvSpPr/>
+          <p:nvPr/>
+        </p:nvSpPr>
+        <p:spPr>
+          <a:xfrm>
+            <a:off x="10397093" y="197510"/>
+            <a:ext cx="373075" cy="373075"/>
+          </a:xfrm>
+          <a:prstGeom prst="ellipse">
+            <a:avLst/>
+          </a:prstGeom>
+          <a:solidFill>
+            <a:srgbClr val="268282"/>
+          </a:solidFill>
+          <a:ln>
+            <a:noFill/>
+          </a:ln>
+        </p:spPr>
+        <p:style>
+          <a:lnRef idx="1">
+            <a:schemeClr val="accent1"/>
+          </a:lnRef>
+          <a:fillRef idx="3">
+            <a:schemeClr val="accent1"/>
+          </a:fillRef>
+          <a:effectRef idx="2">
+            <a:schemeClr val="accent1"/>
+          </a:effectRef>
+          <a:fontRef idx="minor">
+            <a:schemeClr val="lt1"/>
+          </a:fontRef>
+        </p:style>
+        <p:txBody>
+          <a:bodyPr rtlCol="0" anchor="ctr"/>
+          <a:lstStyle/>
+          <a:p>
+            <a:pPr algn="ctr"/>
+          </a:p>
+        </p:txBody>
+      </p:sp>
+      <p:sp>
+        <p:nvSpPr>
+          <p:cNvPr id="60" name="logo_text"/>
+          <p:cNvSpPr txBox="1"/>
+          <p:nvPr/>
+        </p:nvSpPr>
+        <p:spPr>
+          <a:xfrm>
+            <a:off x="10843686" y="201168"/>
+            <a:ext cx="1134953" cy="241401"/>
           </a:xfrm>
           <a:prstGeom prst="rect">
             <a:avLst/>
@@ -14410,48 +14919,84 @@
           </a:bodyPr>
           <a:lstStyle/>
           <a:p>
-            <a:pPr algn="ctr"/>
-            <a:r>
-              <a:rPr b="1" sz="1400">
+            <a:pPr algn="l"/>
+            <a:r>
+              <a:rPr sz="750" b="1">
+                <a:solidFill>
+                  <a:srgbClr val="EEF7F7"/>
+                </a:solidFill>
+                <a:latin typeface="Helvetica Neue"/>
+              </a:rPr>
+              <a:t>VELA SYNC</a:t>
+            </a:r>
+          </a:p>
+        </p:txBody>
+      </p:sp>
+      <p:sp>
+        <p:nvSpPr>
+          <p:cNvPr id="61" name="logo_subtext"/>
+          <p:cNvSpPr txBox="1"/>
+          <p:nvPr/>
+        </p:nvSpPr>
+        <p:spPr>
+          <a:xfrm>
+            <a:off x="10843686" y="405993"/>
+            <a:ext cx="1134953" cy="175564"/>
+          </a:xfrm>
+          <a:prstGeom prst="rect">
+            <a:avLst/>
+          </a:prstGeom>
+          <a:noFill/>
+        </p:spPr>
+        <p:txBody>
+          <a:bodyPr wrap="none">
+            <a:spAutoFit/>
+          </a:bodyPr>
+          <a:lstStyle/>
+          <a:p>
+            <a:pPr algn="l"/>
+            <a:r>
+              <a:rPr sz="500">
+                <a:solidFill>
+                  <a:srgbClr val="3AAEAE"/>
+                </a:solidFill>
+                <a:latin typeface="Helvetica Neue"/>
+              </a:rPr>
+              <a:t>velasync.co.uk</a:t>
+            </a:r>
+          </a:p>
+        </p:txBody>
+      </p:sp>
+      <p:sp>
+        <p:nvSpPr>
+          <p:cNvPr id="63" name="logo_icon"/>
+          <p:cNvSpPr txBox="1"/>
+          <p:nvPr/>
+        </p:nvSpPr>
+        <p:spPr>
+          <a:xfrm>
+            <a:off x="10441862" y="216164"/>
+            <a:ext cx="283537" cy="298460"/>
+          </a:xfrm>
+          <a:prstGeom prst="rect">
+            <a:avLst/>
+          </a:prstGeom>
+          <a:noFill/>
+        </p:spPr>
+        <p:txBody>
+          <a:bodyPr wrap="none">
+            <a:spAutoFit/>
+          </a:bodyPr>
+          <a:lstStyle/>
+          <a:p>
+            <a:pPr algn="ctr"/>
+            <a:r>
+              <a:rPr sz="1527">
                 <a:solidFill>
                   <a:srgbClr val="FFFFFF"/>
                 </a:solidFill>
               </a:rPr>
-              <a:t>VS</a:t>
-            </a:r>
-          </a:p>
-        </p:txBody>
-      </p:sp>
-      <p:sp>
-        <p:nvSpPr>
-          <p:cNvPr id="57" name="TextBox 56"/>
-          <p:cNvSpPr txBox="1"/>
-          <p:nvPr/>
-        </p:nvSpPr>
-        <p:spPr>
-          <a:xfrm>
-            <a:off x="10360152" y="320040"/>
-            <a:ext cx="1005840" cy="274320"/>
-          </a:xfrm>
-          <a:prstGeom prst="rect">
-            <a:avLst/>
-          </a:prstGeom>
-          <a:noFill/>
-        </p:spPr>
-        <p:txBody>
-          <a:bodyPr wrap="none">
-            <a:spAutoFit/>
-          </a:bodyPr>
-          <a:lstStyle/>
-          <a:p>
-            <a:pPr algn="r"/>
-            <a:r>
-              <a:rPr b="1" sz="800">
-                <a:solidFill>
-                  <a:srgbClr val="EEF7F7"/>
-                </a:solidFill>
-              </a:rPr>
-              <a:t>VELA SYNC</a:t>
+              <a:t>⛵</a:t>
             </a:r>
           </a:p>
         </p:txBody>
@@ -18043,23 +18588,61 @@
       </p:sp>
       <p:sp>
         <p:nvSpPr>
-          <p:cNvPr id="97" name="Rectangle 96"/>
+          <p:cNvPr id="99" name="TextBox 98"/>
+          <p:cNvSpPr txBox="1"/>
+          <p:nvPr/>
+        </p:nvSpPr>
+        <p:spPr>
+          <a:xfrm>
+            <a:off x="10360152" y="320040"/>
+            <a:ext cx="1005840" cy="274320"/>
+          </a:xfrm>
+          <a:prstGeom prst="rect">
+            <a:avLst/>
+          </a:prstGeom>
+          <a:noFill/>
+        </p:spPr>
+        <p:txBody>
+          <a:bodyPr wrap="none">
+            <a:spAutoFit/>
+          </a:bodyPr>
+          <a:lstStyle/>
+          <a:p>
+            <a:pPr algn="r"/>
+            <a:r>
+              <a:rPr b="1" sz="800">
+                <a:solidFill>
+                  <a:srgbClr val="EEF7F7"/>
+                </a:solidFill>
+              </a:rPr>
+              <a:t>VELA SYNC</a:t>
+            </a:r>
+          </a:p>
+        </p:txBody>
+      </p:sp>
+      <p:sp>
+        <p:nvSpPr>
+          <p:cNvPr id="100" name="logo_bg"/>
           <p:cNvSpPr/>
           <p:nvPr/>
         </p:nvSpPr>
         <p:spPr>
           <a:xfrm>
-            <a:off x="11411712" y="228600"/>
-            <a:ext cx="457200" cy="457200"/>
-          </a:xfrm>
-          <a:prstGeom prst="rect">
-            <a:avLst/>
-          </a:prstGeom>
-          <a:solidFill>
-            <a:srgbClr val="2B8E8E"/>
-          </a:solidFill>
-          <a:ln>
-            <a:noFill/>
+            <a:off x="10378440" y="164592"/>
+            <a:ext cx="1600200" cy="438912"/>
+          </a:xfrm>
+          <a:prstGeom prst="roundRect">
+            <a:avLst>
+              <a:gd name="adj" fmla="val 25000"/>
+            </a:avLst>
+          </a:prstGeom>
+          <a:solidFill>
+            <a:srgbClr val="0F1A1A"/>
+          </a:solidFill>
+          <a:ln w="7620">
+            <a:solidFill>
+              <a:srgbClr val="268282"/>
+            </a:solidFill>
           </a:ln>
         </p:spPr>
         <p:style>
@@ -18086,14 +18669,57 @@
       </p:sp>
       <p:sp>
         <p:nvSpPr>
-          <p:cNvPr id="98" name="TextBox 97"/>
-          <p:cNvSpPr txBox="1"/>
-          <p:nvPr/>
-        </p:nvSpPr>
-        <p:spPr>
-          <a:xfrm>
-            <a:off x="11411712" y="228600"/>
-            <a:ext cx="457200" cy="457200"/>
+          <p:cNvPr id="101" name="logo_circle"/>
+          <p:cNvSpPr/>
+          <p:nvPr/>
+        </p:nvSpPr>
+        <p:spPr>
+          <a:xfrm>
+            <a:off x="10397093" y="197510"/>
+            <a:ext cx="373075" cy="373075"/>
+          </a:xfrm>
+          <a:prstGeom prst="ellipse">
+            <a:avLst/>
+          </a:prstGeom>
+          <a:solidFill>
+            <a:srgbClr val="268282"/>
+          </a:solidFill>
+          <a:ln>
+            <a:noFill/>
+          </a:ln>
+        </p:spPr>
+        <p:style>
+          <a:lnRef idx="1">
+            <a:schemeClr val="accent1"/>
+          </a:lnRef>
+          <a:fillRef idx="3">
+            <a:schemeClr val="accent1"/>
+          </a:fillRef>
+          <a:effectRef idx="2">
+            <a:schemeClr val="accent1"/>
+          </a:effectRef>
+          <a:fontRef idx="minor">
+            <a:schemeClr val="lt1"/>
+          </a:fontRef>
+        </p:style>
+        <p:txBody>
+          <a:bodyPr rtlCol="0" anchor="ctr"/>
+          <a:lstStyle/>
+          <a:p>
+            <a:pPr algn="ctr"/>
+          </a:p>
+        </p:txBody>
+      </p:sp>
+      <p:sp>
+        <p:nvSpPr>
+          <p:cNvPr id="102" name="logo_text"/>
+          <p:cNvSpPr txBox="1"/>
+          <p:nvPr/>
+        </p:nvSpPr>
+        <p:spPr>
+          <a:xfrm>
+            <a:off x="10843686" y="201168"/>
+            <a:ext cx="1134953" cy="241401"/>
           </a:xfrm>
           <a:prstGeom prst="rect">
             <a:avLst/>
@@ -18106,48 +18732,84 @@
           </a:bodyPr>
           <a:lstStyle/>
           <a:p>
-            <a:pPr algn="ctr"/>
-            <a:r>
-              <a:rPr b="1" sz="1400">
+            <a:pPr algn="l"/>
+            <a:r>
+              <a:rPr sz="750" b="1">
+                <a:solidFill>
+                  <a:srgbClr val="EEF7F7"/>
+                </a:solidFill>
+                <a:latin typeface="Helvetica Neue"/>
+              </a:rPr>
+              <a:t>VELA SYNC</a:t>
+            </a:r>
+          </a:p>
+        </p:txBody>
+      </p:sp>
+      <p:sp>
+        <p:nvSpPr>
+          <p:cNvPr id="103" name="logo_subtext"/>
+          <p:cNvSpPr txBox="1"/>
+          <p:nvPr/>
+        </p:nvSpPr>
+        <p:spPr>
+          <a:xfrm>
+            <a:off x="10843686" y="405993"/>
+            <a:ext cx="1134953" cy="175564"/>
+          </a:xfrm>
+          <a:prstGeom prst="rect">
+            <a:avLst/>
+          </a:prstGeom>
+          <a:noFill/>
+        </p:spPr>
+        <p:txBody>
+          <a:bodyPr wrap="none">
+            <a:spAutoFit/>
+          </a:bodyPr>
+          <a:lstStyle/>
+          <a:p>
+            <a:pPr algn="l"/>
+            <a:r>
+              <a:rPr sz="500">
+                <a:solidFill>
+                  <a:srgbClr val="3AAEAE"/>
+                </a:solidFill>
+                <a:latin typeface="Helvetica Neue"/>
+              </a:rPr>
+              <a:t>velasync.co.uk</a:t>
+            </a:r>
+          </a:p>
+        </p:txBody>
+      </p:sp>
+      <p:sp>
+        <p:nvSpPr>
+          <p:cNvPr id="105" name="logo_icon"/>
+          <p:cNvSpPr txBox="1"/>
+          <p:nvPr/>
+        </p:nvSpPr>
+        <p:spPr>
+          <a:xfrm>
+            <a:off x="10441862" y="216164"/>
+            <a:ext cx="283537" cy="298460"/>
+          </a:xfrm>
+          <a:prstGeom prst="rect">
+            <a:avLst/>
+          </a:prstGeom>
+          <a:noFill/>
+        </p:spPr>
+        <p:txBody>
+          <a:bodyPr wrap="none">
+            <a:spAutoFit/>
+          </a:bodyPr>
+          <a:lstStyle/>
+          <a:p>
+            <a:pPr algn="ctr"/>
+            <a:r>
+              <a:rPr sz="1527">
                 <a:solidFill>
                   <a:srgbClr val="FFFFFF"/>
                 </a:solidFill>
               </a:rPr>
-              <a:t>VS</a:t>
-            </a:r>
-          </a:p>
-        </p:txBody>
-      </p:sp>
-      <p:sp>
-        <p:nvSpPr>
-          <p:cNvPr id="99" name="TextBox 98"/>
-          <p:cNvSpPr txBox="1"/>
-          <p:nvPr/>
-        </p:nvSpPr>
-        <p:spPr>
-          <a:xfrm>
-            <a:off x="10360152" y="320040"/>
-            <a:ext cx="1005840" cy="274320"/>
-          </a:xfrm>
-          <a:prstGeom prst="rect">
-            <a:avLst/>
-          </a:prstGeom>
-          <a:noFill/>
-        </p:spPr>
-        <p:txBody>
-          <a:bodyPr wrap="none">
-            <a:spAutoFit/>
-          </a:bodyPr>
-          <a:lstStyle/>
-          <a:p>
-            <a:pPr algn="r"/>
-            <a:r>
-              <a:rPr b="1" sz="800">
-                <a:solidFill>
-                  <a:srgbClr val="EEF7F7"/>
-                </a:solidFill>
-              </a:rPr>
-              <a:t>VELA SYNC</a:t>
+              <a:t>⛵</a:t>
             </a:r>
           </a:p>
         </p:txBody>
@@ -19960,23 +20622,61 @@
       </p:sp>
       <p:sp>
         <p:nvSpPr>
-          <p:cNvPr id="48" name="Rectangle 47"/>
+          <p:cNvPr id="50" name="TextBox 49"/>
+          <p:cNvSpPr txBox="1"/>
+          <p:nvPr/>
+        </p:nvSpPr>
+        <p:spPr>
+          <a:xfrm>
+            <a:off x="10360152" y="320040"/>
+            <a:ext cx="1005840" cy="274320"/>
+          </a:xfrm>
+          <a:prstGeom prst="rect">
+            <a:avLst/>
+          </a:prstGeom>
+          <a:noFill/>
+        </p:spPr>
+        <p:txBody>
+          <a:bodyPr wrap="none">
+            <a:spAutoFit/>
+          </a:bodyPr>
+          <a:lstStyle/>
+          <a:p>
+            <a:pPr algn="r"/>
+            <a:r>
+              <a:rPr b="1" sz="800">
+                <a:solidFill>
+                  <a:srgbClr val="EEF7F7"/>
+                </a:solidFill>
+              </a:rPr>
+              <a:t>VELA SYNC</a:t>
+            </a:r>
+          </a:p>
+        </p:txBody>
+      </p:sp>
+      <p:sp>
+        <p:nvSpPr>
+          <p:cNvPr id="51" name="logo_bg"/>
           <p:cNvSpPr/>
           <p:nvPr/>
         </p:nvSpPr>
         <p:spPr>
           <a:xfrm>
-            <a:off x="11411712" y="228600"/>
-            <a:ext cx="457200" cy="457200"/>
-          </a:xfrm>
-          <a:prstGeom prst="rect">
-            <a:avLst/>
-          </a:prstGeom>
-          <a:solidFill>
-            <a:srgbClr val="2B8E8E"/>
-          </a:solidFill>
-          <a:ln>
-            <a:noFill/>
+            <a:off x="10378440" y="164592"/>
+            <a:ext cx="1600200" cy="438912"/>
+          </a:xfrm>
+          <a:prstGeom prst="roundRect">
+            <a:avLst>
+              <a:gd name="adj" fmla="val 25000"/>
+            </a:avLst>
+          </a:prstGeom>
+          <a:solidFill>
+            <a:srgbClr val="0F1A1A"/>
+          </a:solidFill>
+          <a:ln w="7620">
+            <a:solidFill>
+              <a:srgbClr val="268282"/>
+            </a:solidFill>
           </a:ln>
         </p:spPr>
         <p:style>
@@ -20003,14 +20703,57 @@
       </p:sp>
       <p:sp>
         <p:nvSpPr>
-          <p:cNvPr id="49" name="TextBox 48"/>
-          <p:cNvSpPr txBox="1"/>
-          <p:nvPr/>
-        </p:nvSpPr>
-        <p:spPr>
-          <a:xfrm>
-            <a:off x="11411712" y="228600"/>
-            <a:ext cx="457200" cy="457200"/>
+          <p:cNvPr id="52" name="logo_circle"/>
+          <p:cNvSpPr/>
+          <p:nvPr/>
+        </p:nvSpPr>
+        <p:spPr>
+          <a:xfrm>
+            <a:off x="10397093" y="197510"/>
+            <a:ext cx="373075" cy="373075"/>
+          </a:xfrm>
+          <a:prstGeom prst="ellipse">
+            <a:avLst/>
+          </a:prstGeom>
+          <a:solidFill>
+            <a:srgbClr val="268282"/>
+          </a:solidFill>
+          <a:ln>
+            <a:noFill/>
+          </a:ln>
+        </p:spPr>
+        <p:style>
+          <a:lnRef idx="1">
+            <a:schemeClr val="accent1"/>
+          </a:lnRef>
+          <a:fillRef idx="3">
+            <a:schemeClr val="accent1"/>
+          </a:fillRef>
+          <a:effectRef idx="2">
+            <a:schemeClr val="accent1"/>
+          </a:effectRef>
+          <a:fontRef idx="minor">
+            <a:schemeClr val="lt1"/>
+          </a:fontRef>
+        </p:style>
+        <p:txBody>
+          <a:bodyPr rtlCol="0" anchor="ctr"/>
+          <a:lstStyle/>
+          <a:p>
+            <a:pPr algn="ctr"/>
+          </a:p>
+        </p:txBody>
+      </p:sp>
+      <p:sp>
+        <p:nvSpPr>
+          <p:cNvPr id="53" name="logo_text"/>
+          <p:cNvSpPr txBox="1"/>
+          <p:nvPr/>
+        </p:nvSpPr>
+        <p:spPr>
+          <a:xfrm>
+            <a:off x="10843686" y="201168"/>
+            <a:ext cx="1134953" cy="241401"/>
           </a:xfrm>
           <a:prstGeom prst="rect">
             <a:avLst/>
@@ -20023,48 +20766,84 @@
           </a:bodyPr>
           <a:lstStyle/>
           <a:p>
-            <a:pPr algn="ctr"/>
-            <a:r>
-              <a:rPr b="1" sz="1400">
+            <a:pPr algn="l"/>
+            <a:r>
+              <a:rPr sz="750" b="1">
+                <a:solidFill>
+                  <a:srgbClr val="EEF7F7"/>
+                </a:solidFill>
+                <a:latin typeface="Helvetica Neue"/>
+              </a:rPr>
+              <a:t>VELA SYNC</a:t>
+            </a:r>
+          </a:p>
+        </p:txBody>
+      </p:sp>
+      <p:sp>
+        <p:nvSpPr>
+          <p:cNvPr id="54" name="logo_subtext"/>
+          <p:cNvSpPr txBox="1"/>
+          <p:nvPr/>
+        </p:nvSpPr>
+        <p:spPr>
+          <a:xfrm>
+            <a:off x="10843686" y="405993"/>
+            <a:ext cx="1134953" cy="175564"/>
+          </a:xfrm>
+          <a:prstGeom prst="rect">
+            <a:avLst/>
+          </a:prstGeom>
+          <a:noFill/>
+        </p:spPr>
+        <p:txBody>
+          <a:bodyPr wrap="none">
+            <a:spAutoFit/>
+          </a:bodyPr>
+          <a:lstStyle/>
+          <a:p>
+            <a:pPr algn="l"/>
+            <a:r>
+              <a:rPr sz="500">
+                <a:solidFill>
+                  <a:srgbClr val="3AAEAE"/>
+                </a:solidFill>
+                <a:latin typeface="Helvetica Neue"/>
+              </a:rPr>
+              <a:t>velasync.co.uk</a:t>
+            </a:r>
+          </a:p>
+        </p:txBody>
+      </p:sp>
+      <p:sp>
+        <p:nvSpPr>
+          <p:cNvPr id="56" name="logo_icon"/>
+          <p:cNvSpPr txBox="1"/>
+          <p:nvPr/>
+        </p:nvSpPr>
+        <p:spPr>
+          <a:xfrm>
+            <a:off x="10441862" y="216164"/>
+            <a:ext cx="283537" cy="298460"/>
+          </a:xfrm>
+          <a:prstGeom prst="rect">
+            <a:avLst/>
+          </a:prstGeom>
+          <a:noFill/>
+        </p:spPr>
+        <p:txBody>
+          <a:bodyPr wrap="none">
+            <a:spAutoFit/>
+          </a:bodyPr>
+          <a:lstStyle/>
+          <a:p>
+            <a:pPr algn="ctr"/>
+            <a:r>
+              <a:rPr sz="1527">
                 <a:solidFill>
                   <a:srgbClr val="FFFFFF"/>
                 </a:solidFill>
               </a:rPr>
-              <a:t>VS</a:t>
-            </a:r>
-          </a:p>
-        </p:txBody>
-      </p:sp>
-      <p:sp>
-        <p:nvSpPr>
-          <p:cNvPr id="50" name="TextBox 49"/>
-          <p:cNvSpPr txBox="1"/>
-          <p:nvPr/>
-        </p:nvSpPr>
-        <p:spPr>
-          <a:xfrm>
-            <a:off x="10360152" y="320040"/>
-            <a:ext cx="1005840" cy="274320"/>
-          </a:xfrm>
-          <a:prstGeom prst="rect">
-            <a:avLst/>
-          </a:prstGeom>
-          <a:noFill/>
-        </p:spPr>
-        <p:txBody>
-          <a:bodyPr wrap="none">
-            <a:spAutoFit/>
-          </a:bodyPr>
-          <a:lstStyle/>
-          <a:p>
-            <a:pPr algn="r"/>
-            <a:r>
-              <a:rPr b="1" sz="800">
-                <a:solidFill>
-                  <a:srgbClr val="EEF7F7"/>
-                </a:solidFill>
-              </a:rPr>
-              <a:t>VELA SYNC</a:t>
+              <a:t>⛵</a:t>
             </a:r>
           </a:p>
         </p:txBody>
@@ -21827,23 +22606,61 @@
       </p:sp>
       <p:sp>
         <p:nvSpPr>
-          <p:cNvPr id="48" name="Rectangle 47"/>
+          <p:cNvPr id="50" name="TextBox 49"/>
+          <p:cNvSpPr txBox="1"/>
+          <p:nvPr/>
+        </p:nvSpPr>
+        <p:spPr>
+          <a:xfrm>
+            <a:off x="10360152" y="320040"/>
+            <a:ext cx="1005840" cy="274320"/>
+          </a:xfrm>
+          <a:prstGeom prst="rect">
+            <a:avLst/>
+          </a:prstGeom>
+          <a:noFill/>
+        </p:spPr>
+        <p:txBody>
+          <a:bodyPr wrap="none">
+            <a:spAutoFit/>
+          </a:bodyPr>
+          <a:lstStyle/>
+          <a:p>
+            <a:pPr algn="r"/>
+            <a:r>
+              <a:rPr b="1" sz="800">
+                <a:solidFill>
+                  <a:srgbClr val="EEF7F7"/>
+                </a:solidFill>
+              </a:rPr>
+              <a:t>VELA SYNC</a:t>
+            </a:r>
+          </a:p>
+        </p:txBody>
+      </p:sp>
+      <p:sp>
+        <p:nvSpPr>
+          <p:cNvPr id="51" name="logo_bg"/>
           <p:cNvSpPr/>
           <p:nvPr/>
         </p:nvSpPr>
         <p:spPr>
           <a:xfrm>
-            <a:off x="11411712" y="228600"/>
-            <a:ext cx="457200" cy="457200"/>
-          </a:xfrm>
-          <a:prstGeom prst="rect">
-            <a:avLst/>
-          </a:prstGeom>
-          <a:solidFill>
-            <a:srgbClr val="2B8E8E"/>
-          </a:solidFill>
-          <a:ln>
-            <a:noFill/>
+            <a:off x="10378440" y="164592"/>
+            <a:ext cx="1600200" cy="438912"/>
+          </a:xfrm>
+          <a:prstGeom prst="roundRect">
+            <a:avLst>
+              <a:gd name="adj" fmla="val 25000"/>
+            </a:avLst>
+          </a:prstGeom>
+          <a:solidFill>
+            <a:srgbClr val="0F1A1A"/>
+          </a:solidFill>
+          <a:ln w="7620">
+            <a:solidFill>
+              <a:srgbClr val="268282"/>
+            </a:solidFill>
           </a:ln>
         </p:spPr>
         <p:style>
@@ -21870,14 +22687,57 @@
       </p:sp>
       <p:sp>
         <p:nvSpPr>
-          <p:cNvPr id="49" name="TextBox 48"/>
-          <p:cNvSpPr txBox="1"/>
-          <p:nvPr/>
-        </p:nvSpPr>
-        <p:spPr>
-          <a:xfrm>
-            <a:off x="11411712" y="228600"/>
-            <a:ext cx="457200" cy="457200"/>
+          <p:cNvPr id="52" name="logo_circle"/>
+          <p:cNvSpPr/>
+          <p:nvPr/>
+        </p:nvSpPr>
+        <p:spPr>
+          <a:xfrm>
+            <a:off x="10397093" y="197510"/>
+            <a:ext cx="373075" cy="373075"/>
+          </a:xfrm>
+          <a:prstGeom prst="ellipse">
+            <a:avLst/>
+          </a:prstGeom>
+          <a:solidFill>
+            <a:srgbClr val="268282"/>
+          </a:solidFill>
+          <a:ln>
+            <a:noFill/>
+          </a:ln>
+        </p:spPr>
+        <p:style>
+          <a:lnRef idx="1">
+            <a:schemeClr val="accent1"/>
+          </a:lnRef>
+          <a:fillRef idx="3">
+            <a:schemeClr val="accent1"/>
+          </a:fillRef>
+          <a:effectRef idx="2">
+            <a:schemeClr val="accent1"/>
+          </a:effectRef>
+          <a:fontRef idx="minor">
+            <a:schemeClr val="lt1"/>
+          </a:fontRef>
+        </p:style>
+        <p:txBody>
+          <a:bodyPr rtlCol="0" anchor="ctr"/>
+          <a:lstStyle/>
+          <a:p>
+            <a:pPr algn="ctr"/>
+          </a:p>
+        </p:txBody>
+      </p:sp>
+      <p:sp>
+        <p:nvSpPr>
+          <p:cNvPr id="53" name="logo_text"/>
+          <p:cNvSpPr txBox="1"/>
+          <p:nvPr/>
+        </p:nvSpPr>
+        <p:spPr>
+          <a:xfrm>
+            <a:off x="10843686" y="201168"/>
+            <a:ext cx="1134953" cy="241401"/>
           </a:xfrm>
           <a:prstGeom prst="rect">
             <a:avLst/>
@@ -21890,48 +22750,84 @@
           </a:bodyPr>
           <a:lstStyle/>
           <a:p>
-            <a:pPr algn="ctr"/>
-            <a:r>
-              <a:rPr b="1" sz="1400">
+            <a:pPr algn="l"/>
+            <a:r>
+              <a:rPr sz="750" b="1">
+                <a:solidFill>
+                  <a:srgbClr val="EEF7F7"/>
+                </a:solidFill>
+                <a:latin typeface="Helvetica Neue"/>
+              </a:rPr>
+              <a:t>VELA SYNC</a:t>
+            </a:r>
+          </a:p>
+        </p:txBody>
+      </p:sp>
+      <p:sp>
+        <p:nvSpPr>
+          <p:cNvPr id="54" name="logo_subtext"/>
+          <p:cNvSpPr txBox="1"/>
+          <p:nvPr/>
+        </p:nvSpPr>
+        <p:spPr>
+          <a:xfrm>
+            <a:off x="10843686" y="405993"/>
+            <a:ext cx="1134953" cy="175564"/>
+          </a:xfrm>
+          <a:prstGeom prst="rect">
+            <a:avLst/>
+          </a:prstGeom>
+          <a:noFill/>
+        </p:spPr>
+        <p:txBody>
+          <a:bodyPr wrap="none">
+            <a:spAutoFit/>
+          </a:bodyPr>
+          <a:lstStyle/>
+          <a:p>
+            <a:pPr algn="l"/>
+            <a:r>
+              <a:rPr sz="500">
+                <a:solidFill>
+                  <a:srgbClr val="3AAEAE"/>
+                </a:solidFill>
+                <a:latin typeface="Helvetica Neue"/>
+              </a:rPr>
+              <a:t>velasync.co.uk</a:t>
+            </a:r>
+          </a:p>
+        </p:txBody>
+      </p:sp>
+      <p:sp>
+        <p:nvSpPr>
+          <p:cNvPr id="56" name="logo_icon"/>
+          <p:cNvSpPr txBox="1"/>
+          <p:nvPr/>
+        </p:nvSpPr>
+        <p:spPr>
+          <a:xfrm>
+            <a:off x="10441862" y="216164"/>
+            <a:ext cx="283537" cy="298460"/>
+          </a:xfrm>
+          <a:prstGeom prst="rect">
+            <a:avLst/>
+          </a:prstGeom>
+          <a:noFill/>
+        </p:spPr>
+        <p:txBody>
+          <a:bodyPr wrap="none">
+            <a:spAutoFit/>
+          </a:bodyPr>
+          <a:lstStyle/>
+          <a:p>
+            <a:pPr algn="ctr"/>
+            <a:r>
+              <a:rPr sz="1527">
                 <a:solidFill>
                   <a:srgbClr val="FFFFFF"/>
                 </a:solidFill>
               </a:rPr>
-              <a:t>VS</a:t>
-            </a:r>
-          </a:p>
-        </p:txBody>
-      </p:sp>
-      <p:sp>
-        <p:nvSpPr>
-          <p:cNvPr id="50" name="TextBox 49"/>
-          <p:cNvSpPr txBox="1"/>
-          <p:nvPr/>
-        </p:nvSpPr>
-        <p:spPr>
-          <a:xfrm>
-            <a:off x="10360152" y="320040"/>
-            <a:ext cx="1005840" cy="274320"/>
-          </a:xfrm>
-          <a:prstGeom prst="rect">
-            <a:avLst/>
-          </a:prstGeom>
-          <a:noFill/>
-        </p:spPr>
-        <p:txBody>
-          <a:bodyPr wrap="none">
-            <a:spAutoFit/>
-          </a:bodyPr>
-          <a:lstStyle/>
-          <a:p>
-            <a:pPr algn="r"/>
-            <a:r>
-              <a:rPr b="1" sz="800">
-                <a:solidFill>
-                  <a:srgbClr val="EEF7F7"/>
-                </a:solidFill>
-              </a:rPr>
-              <a:t>VELA SYNC</a:t>
+              <a:t>⛵</a:t>
             </a:r>
           </a:p>
         </p:txBody>
@@ -23643,23 +24539,61 @@
       </p:sp>
       <p:sp>
         <p:nvSpPr>
-          <p:cNvPr id="47" name="Rectangle 46"/>
+          <p:cNvPr id="49" name="TextBox 48"/>
+          <p:cNvSpPr txBox="1"/>
+          <p:nvPr/>
+        </p:nvSpPr>
+        <p:spPr>
+          <a:xfrm>
+            <a:off x="10360152" y="320040"/>
+            <a:ext cx="1005840" cy="274320"/>
+          </a:xfrm>
+          <a:prstGeom prst="rect">
+            <a:avLst/>
+          </a:prstGeom>
+          <a:noFill/>
+        </p:spPr>
+        <p:txBody>
+          <a:bodyPr wrap="none">
+            <a:spAutoFit/>
+          </a:bodyPr>
+          <a:lstStyle/>
+          <a:p>
+            <a:pPr algn="r"/>
+            <a:r>
+              <a:rPr b="1" sz="800">
+                <a:solidFill>
+                  <a:srgbClr val="EEF7F7"/>
+                </a:solidFill>
+              </a:rPr>
+              <a:t>VELA SYNC</a:t>
+            </a:r>
+          </a:p>
+        </p:txBody>
+      </p:sp>
+      <p:sp>
+        <p:nvSpPr>
+          <p:cNvPr id="50" name="logo_bg"/>
           <p:cNvSpPr/>
           <p:nvPr/>
         </p:nvSpPr>
         <p:spPr>
           <a:xfrm>
-            <a:off x="11411712" y="228600"/>
-            <a:ext cx="457200" cy="457200"/>
-          </a:xfrm>
-          <a:prstGeom prst="rect">
-            <a:avLst/>
-          </a:prstGeom>
-          <a:solidFill>
-            <a:srgbClr val="2B8E8E"/>
-          </a:solidFill>
-          <a:ln>
-            <a:noFill/>
+            <a:off x="10378440" y="164592"/>
+            <a:ext cx="1600200" cy="438912"/>
+          </a:xfrm>
+          <a:prstGeom prst="roundRect">
+            <a:avLst>
+              <a:gd name="adj" fmla="val 25000"/>
+            </a:avLst>
+          </a:prstGeom>
+          <a:solidFill>
+            <a:srgbClr val="0F1A1A"/>
+          </a:solidFill>
+          <a:ln w="7620">
+            <a:solidFill>
+              <a:srgbClr val="268282"/>
+            </a:solidFill>
           </a:ln>
         </p:spPr>
         <p:style>
@@ -23686,14 +24620,57 @@
       </p:sp>
       <p:sp>
         <p:nvSpPr>
-          <p:cNvPr id="48" name="TextBox 47"/>
-          <p:cNvSpPr txBox="1"/>
-          <p:nvPr/>
-        </p:nvSpPr>
-        <p:spPr>
-          <a:xfrm>
-            <a:off x="11411712" y="228600"/>
-            <a:ext cx="457200" cy="457200"/>
+          <p:cNvPr id="51" name="logo_circle"/>
+          <p:cNvSpPr/>
+          <p:nvPr/>
+        </p:nvSpPr>
+        <p:spPr>
+          <a:xfrm>
+            <a:off x="10397093" y="197510"/>
+            <a:ext cx="373075" cy="373075"/>
+          </a:xfrm>
+          <a:prstGeom prst="ellipse">
+            <a:avLst/>
+          </a:prstGeom>
+          <a:solidFill>
+            <a:srgbClr val="268282"/>
+          </a:solidFill>
+          <a:ln>
+            <a:noFill/>
+          </a:ln>
+        </p:spPr>
+        <p:style>
+          <a:lnRef idx="1">
+            <a:schemeClr val="accent1"/>
+          </a:lnRef>
+          <a:fillRef idx="3">
+            <a:schemeClr val="accent1"/>
+          </a:fillRef>
+          <a:effectRef idx="2">
+            <a:schemeClr val="accent1"/>
+          </a:effectRef>
+          <a:fontRef idx="minor">
+            <a:schemeClr val="lt1"/>
+          </a:fontRef>
+        </p:style>
+        <p:txBody>
+          <a:bodyPr rtlCol="0" anchor="ctr"/>
+          <a:lstStyle/>
+          <a:p>
+            <a:pPr algn="ctr"/>
+          </a:p>
+        </p:txBody>
+      </p:sp>
+      <p:sp>
+        <p:nvSpPr>
+          <p:cNvPr id="52" name="logo_text"/>
+          <p:cNvSpPr txBox="1"/>
+          <p:nvPr/>
+        </p:nvSpPr>
+        <p:spPr>
+          <a:xfrm>
+            <a:off x="10843686" y="201168"/>
+            <a:ext cx="1134953" cy="241401"/>
           </a:xfrm>
           <a:prstGeom prst="rect">
             <a:avLst/>
@@ -23706,48 +24683,84 @@
           </a:bodyPr>
           <a:lstStyle/>
           <a:p>
-            <a:pPr algn="ctr"/>
-            <a:r>
-              <a:rPr b="1" sz="1400">
+            <a:pPr algn="l"/>
+            <a:r>
+              <a:rPr sz="750" b="1">
+                <a:solidFill>
+                  <a:srgbClr val="EEF7F7"/>
+                </a:solidFill>
+                <a:latin typeface="Helvetica Neue"/>
+              </a:rPr>
+              <a:t>VELA SYNC</a:t>
+            </a:r>
+          </a:p>
+        </p:txBody>
+      </p:sp>
+      <p:sp>
+        <p:nvSpPr>
+          <p:cNvPr id="53" name="logo_subtext"/>
+          <p:cNvSpPr txBox="1"/>
+          <p:nvPr/>
+        </p:nvSpPr>
+        <p:spPr>
+          <a:xfrm>
+            <a:off x="10843686" y="405993"/>
+            <a:ext cx="1134953" cy="175564"/>
+          </a:xfrm>
+          <a:prstGeom prst="rect">
+            <a:avLst/>
+          </a:prstGeom>
+          <a:noFill/>
+        </p:spPr>
+        <p:txBody>
+          <a:bodyPr wrap="none">
+            <a:spAutoFit/>
+          </a:bodyPr>
+          <a:lstStyle/>
+          <a:p>
+            <a:pPr algn="l"/>
+            <a:r>
+              <a:rPr sz="500">
+                <a:solidFill>
+                  <a:srgbClr val="3AAEAE"/>
+                </a:solidFill>
+                <a:latin typeface="Helvetica Neue"/>
+              </a:rPr>
+              <a:t>velasync.co.uk</a:t>
+            </a:r>
+          </a:p>
+        </p:txBody>
+      </p:sp>
+      <p:sp>
+        <p:nvSpPr>
+          <p:cNvPr id="55" name="logo_icon"/>
+          <p:cNvSpPr txBox="1"/>
+          <p:nvPr/>
+        </p:nvSpPr>
+        <p:spPr>
+          <a:xfrm>
+            <a:off x="10441862" y="216164"/>
+            <a:ext cx="283537" cy="298460"/>
+          </a:xfrm>
+          <a:prstGeom prst="rect">
+            <a:avLst/>
+          </a:prstGeom>
+          <a:noFill/>
+        </p:spPr>
+        <p:txBody>
+          <a:bodyPr wrap="none">
+            <a:spAutoFit/>
+          </a:bodyPr>
+          <a:lstStyle/>
+          <a:p>
+            <a:pPr algn="ctr"/>
+            <a:r>
+              <a:rPr sz="1527">
                 <a:solidFill>
                   <a:srgbClr val="FFFFFF"/>
                 </a:solidFill>
               </a:rPr>
-              <a:t>VS</a:t>
-            </a:r>
-          </a:p>
-        </p:txBody>
-      </p:sp>
-      <p:sp>
-        <p:nvSpPr>
-          <p:cNvPr id="49" name="TextBox 48"/>
-          <p:cNvSpPr txBox="1"/>
-          <p:nvPr/>
-        </p:nvSpPr>
-        <p:spPr>
-          <a:xfrm>
-            <a:off x="10360152" y="320040"/>
-            <a:ext cx="1005840" cy="274320"/>
-          </a:xfrm>
-          <a:prstGeom prst="rect">
-            <a:avLst/>
-          </a:prstGeom>
-          <a:noFill/>
-        </p:spPr>
-        <p:txBody>
-          <a:bodyPr wrap="none">
-            <a:spAutoFit/>
-          </a:bodyPr>
-          <a:lstStyle/>
-          <a:p>
-            <a:pPr algn="r"/>
-            <a:r>
-              <a:rPr b="1" sz="800">
-                <a:solidFill>
-                  <a:srgbClr val="EEF7F7"/>
-                </a:solidFill>
-              </a:rPr>
-              <a:t>VELA SYNC</a:t>
+              <a:t>⛵</a:t>
             </a:r>
           </a:p>
         </p:txBody>
@@ -26487,23 +27500,61 @@
       </p:sp>
       <p:sp>
         <p:nvSpPr>
-          <p:cNvPr id="71" name="Rectangle 70"/>
+          <p:cNvPr id="73" name="TextBox 72"/>
+          <p:cNvSpPr txBox="1"/>
+          <p:nvPr/>
+        </p:nvSpPr>
+        <p:spPr>
+          <a:xfrm>
+            <a:off x="10360152" y="320040"/>
+            <a:ext cx="1005840" cy="274320"/>
+          </a:xfrm>
+          <a:prstGeom prst="rect">
+            <a:avLst/>
+          </a:prstGeom>
+          <a:noFill/>
+        </p:spPr>
+        <p:txBody>
+          <a:bodyPr wrap="none">
+            <a:spAutoFit/>
+          </a:bodyPr>
+          <a:lstStyle/>
+          <a:p>
+            <a:pPr algn="r"/>
+            <a:r>
+              <a:rPr b="1" sz="800">
+                <a:solidFill>
+                  <a:srgbClr val="EEF7F7"/>
+                </a:solidFill>
+              </a:rPr>
+              <a:t>VELA SYNC</a:t>
+            </a:r>
+          </a:p>
+        </p:txBody>
+      </p:sp>
+      <p:sp>
+        <p:nvSpPr>
+          <p:cNvPr id="74" name="logo_bg"/>
           <p:cNvSpPr/>
           <p:nvPr/>
         </p:nvSpPr>
         <p:spPr>
           <a:xfrm>
-            <a:off x="11411712" y="228600"/>
-            <a:ext cx="457200" cy="457200"/>
-          </a:xfrm>
-          <a:prstGeom prst="rect">
-            <a:avLst/>
-          </a:prstGeom>
-          <a:solidFill>
-            <a:srgbClr val="2B8E8E"/>
-          </a:solidFill>
-          <a:ln>
-            <a:noFill/>
+            <a:off x="10378440" y="164592"/>
+            <a:ext cx="1600200" cy="438912"/>
+          </a:xfrm>
+          <a:prstGeom prst="roundRect">
+            <a:avLst>
+              <a:gd name="adj" fmla="val 25000"/>
+            </a:avLst>
+          </a:prstGeom>
+          <a:solidFill>
+            <a:srgbClr val="0F1A1A"/>
+          </a:solidFill>
+          <a:ln w="7620">
+            <a:solidFill>
+              <a:srgbClr val="268282"/>
+            </a:solidFill>
           </a:ln>
         </p:spPr>
         <p:style>
@@ -26530,14 +27581,57 @@
       </p:sp>
       <p:sp>
         <p:nvSpPr>
-          <p:cNvPr id="72" name="TextBox 71"/>
-          <p:cNvSpPr txBox="1"/>
-          <p:nvPr/>
-        </p:nvSpPr>
-        <p:spPr>
-          <a:xfrm>
-            <a:off x="11411712" y="228600"/>
-            <a:ext cx="457200" cy="457200"/>
+          <p:cNvPr id="75" name="logo_circle"/>
+          <p:cNvSpPr/>
+          <p:nvPr/>
+        </p:nvSpPr>
+        <p:spPr>
+          <a:xfrm>
+            <a:off x="10397093" y="197510"/>
+            <a:ext cx="373075" cy="373075"/>
+          </a:xfrm>
+          <a:prstGeom prst="ellipse">
+            <a:avLst/>
+          </a:prstGeom>
+          <a:solidFill>
+            <a:srgbClr val="268282"/>
+          </a:solidFill>
+          <a:ln>
+            <a:noFill/>
+          </a:ln>
+        </p:spPr>
+        <p:style>
+          <a:lnRef idx="1">
+            <a:schemeClr val="accent1"/>
+          </a:lnRef>
+          <a:fillRef idx="3">
+            <a:schemeClr val="accent1"/>
+          </a:fillRef>
+          <a:effectRef idx="2">
+            <a:schemeClr val="accent1"/>
+          </a:effectRef>
+          <a:fontRef idx="minor">
+            <a:schemeClr val="lt1"/>
+          </a:fontRef>
+        </p:style>
+        <p:txBody>
+          <a:bodyPr rtlCol="0" anchor="ctr"/>
+          <a:lstStyle/>
+          <a:p>
+            <a:pPr algn="ctr"/>
+          </a:p>
+        </p:txBody>
+      </p:sp>
+      <p:sp>
+        <p:nvSpPr>
+          <p:cNvPr id="76" name="logo_text"/>
+          <p:cNvSpPr txBox="1"/>
+          <p:nvPr/>
+        </p:nvSpPr>
+        <p:spPr>
+          <a:xfrm>
+            <a:off x="10843686" y="201168"/>
+            <a:ext cx="1134953" cy="241401"/>
           </a:xfrm>
           <a:prstGeom prst="rect">
             <a:avLst/>
@@ -26550,48 +27644,84 @@
           </a:bodyPr>
           <a:lstStyle/>
           <a:p>
-            <a:pPr algn="ctr"/>
-            <a:r>
-              <a:rPr b="1" sz="1400">
+            <a:pPr algn="l"/>
+            <a:r>
+              <a:rPr sz="750" b="1">
+                <a:solidFill>
+                  <a:srgbClr val="EEF7F7"/>
+                </a:solidFill>
+                <a:latin typeface="Helvetica Neue"/>
+              </a:rPr>
+              <a:t>VELA SYNC</a:t>
+            </a:r>
+          </a:p>
+        </p:txBody>
+      </p:sp>
+      <p:sp>
+        <p:nvSpPr>
+          <p:cNvPr id="77" name="logo_subtext"/>
+          <p:cNvSpPr txBox="1"/>
+          <p:nvPr/>
+        </p:nvSpPr>
+        <p:spPr>
+          <a:xfrm>
+            <a:off x="10843686" y="405993"/>
+            <a:ext cx="1134953" cy="175564"/>
+          </a:xfrm>
+          <a:prstGeom prst="rect">
+            <a:avLst/>
+          </a:prstGeom>
+          <a:noFill/>
+        </p:spPr>
+        <p:txBody>
+          <a:bodyPr wrap="none">
+            <a:spAutoFit/>
+          </a:bodyPr>
+          <a:lstStyle/>
+          <a:p>
+            <a:pPr algn="l"/>
+            <a:r>
+              <a:rPr sz="500">
+                <a:solidFill>
+                  <a:srgbClr val="3AAEAE"/>
+                </a:solidFill>
+                <a:latin typeface="Helvetica Neue"/>
+              </a:rPr>
+              <a:t>velasync.co.uk</a:t>
+            </a:r>
+          </a:p>
+        </p:txBody>
+      </p:sp>
+      <p:sp>
+        <p:nvSpPr>
+          <p:cNvPr id="79" name="logo_icon"/>
+          <p:cNvSpPr txBox="1"/>
+          <p:nvPr/>
+        </p:nvSpPr>
+        <p:spPr>
+          <a:xfrm>
+            <a:off x="10441862" y="216164"/>
+            <a:ext cx="283537" cy="298460"/>
+          </a:xfrm>
+          <a:prstGeom prst="rect">
+            <a:avLst/>
+          </a:prstGeom>
+          <a:noFill/>
+        </p:spPr>
+        <p:txBody>
+          <a:bodyPr wrap="none">
+            <a:spAutoFit/>
+          </a:bodyPr>
+          <a:lstStyle/>
+          <a:p>
+            <a:pPr algn="ctr"/>
+            <a:r>
+              <a:rPr sz="1527">
                 <a:solidFill>
                   <a:srgbClr val="FFFFFF"/>
                 </a:solidFill>
               </a:rPr>
-              <a:t>VS</a:t>
-            </a:r>
-          </a:p>
-        </p:txBody>
-      </p:sp>
-      <p:sp>
-        <p:nvSpPr>
-          <p:cNvPr id="73" name="TextBox 72"/>
-          <p:cNvSpPr txBox="1"/>
-          <p:nvPr/>
-        </p:nvSpPr>
-        <p:spPr>
-          <a:xfrm>
-            <a:off x="10360152" y="320040"/>
-            <a:ext cx="1005840" cy="274320"/>
-          </a:xfrm>
-          <a:prstGeom prst="rect">
-            <a:avLst/>
-          </a:prstGeom>
-          <a:noFill/>
-        </p:spPr>
-        <p:txBody>
-          <a:bodyPr wrap="none">
-            <a:spAutoFit/>
-          </a:bodyPr>
-          <a:lstStyle/>
-          <a:p>
-            <a:pPr algn="r"/>
-            <a:r>
-              <a:rPr b="1" sz="800">
-                <a:solidFill>
-                  <a:srgbClr val="EEF7F7"/>
-                </a:solidFill>
-              </a:rPr>
-              <a:t>VELA SYNC</a:t>
+              <a:t>⛵</a:t>
             </a:r>
           </a:p>
         </p:txBody>
@@ -28299,23 +29429,61 @@
       </p:sp>
       <p:sp>
         <p:nvSpPr>
-          <p:cNvPr id="48" name="Rectangle 47"/>
+          <p:cNvPr id="50" name="TextBox 49"/>
+          <p:cNvSpPr txBox="1"/>
+          <p:nvPr/>
+        </p:nvSpPr>
+        <p:spPr>
+          <a:xfrm>
+            <a:off x="10360152" y="320040"/>
+            <a:ext cx="1005840" cy="274320"/>
+          </a:xfrm>
+          <a:prstGeom prst="rect">
+            <a:avLst/>
+          </a:prstGeom>
+          <a:noFill/>
+        </p:spPr>
+        <p:txBody>
+          <a:bodyPr wrap="none">
+            <a:spAutoFit/>
+          </a:bodyPr>
+          <a:lstStyle/>
+          <a:p>
+            <a:pPr algn="r"/>
+            <a:r>
+              <a:rPr b="1" sz="800">
+                <a:solidFill>
+                  <a:srgbClr val="EEF7F7"/>
+                </a:solidFill>
+              </a:rPr>
+              <a:t>VELA SYNC</a:t>
+            </a:r>
+          </a:p>
+        </p:txBody>
+      </p:sp>
+      <p:sp>
+        <p:nvSpPr>
+          <p:cNvPr id="51" name="logo_bg"/>
           <p:cNvSpPr/>
           <p:nvPr/>
         </p:nvSpPr>
         <p:spPr>
           <a:xfrm>
-            <a:off x="11411712" y="228600"/>
-            <a:ext cx="457200" cy="457200"/>
-          </a:xfrm>
-          <a:prstGeom prst="rect">
-            <a:avLst/>
-          </a:prstGeom>
-          <a:solidFill>
-            <a:srgbClr val="2B8E8E"/>
-          </a:solidFill>
-          <a:ln>
-            <a:noFill/>
+            <a:off x="10378440" y="164592"/>
+            <a:ext cx="1600200" cy="438912"/>
+          </a:xfrm>
+          <a:prstGeom prst="roundRect">
+            <a:avLst>
+              <a:gd name="adj" fmla="val 25000"/>
+            </a:avLst>
+          </a:prstGeom>
+          <a:solidFill>
+            <a:srgbClr val="0F1A1A"/>
+          </a:solidFill>
+          <a:ln w="7620">
+            <a:solidFill>
+              <a:srgbClr val="268282"/>
+            </a:solidFill>
           </a:ln>
         </p:spPr>
         <p:style>
@@ -28342,14 +29510,57 @@
       </p:sp>
       <p:sp>
         <p:nvSpPr>
-          <p:cNvPr id="49" name="TextBox 48"/>
-          <p:cNvSpPr txBox="1"/>
-          <p:nvPr/>
-        </p:nvSpPr>
-        <p:spPr>
-          <a:xfrm>
-            <a:off x="11411712" y="228600"/>
-            <a:ext cx="457200" cy="457200"/>
+          <p:cNvPr id="52" name="logo_circle"/>
+          <p:cNvSpPr/>
+          <p:nvPr/>
+        </p:nvSpPr>
+        <p:spPr>
+          <a:xfrm>
+            <a:off x="10397093" y="197510"/>
+            <a:ext cx="373075" cy="373075"/>
+          </a:xfrm>
+          <a:prstGeom prst="ellipse">
+            <a:avLst/>
+          </a:prstGeom>
+          <a:solidFill>
+            <a:srgbClr val="268282"/>
+          </a:solidFill>
+          <a:ln>
+            <a:noFill/>
+          </a:ln>
+        </p:spPr>
+        <p:style>
+          <a:lnRef idx="1">
+            <a:schemeClr val="accent1"/>
+          </a:lnRef>
+          <a:fillRef idx="3">
+            <a:schemeClr val="accent1"/>
+          </a:fillRef>
+          <a:effectRef idx="2">
+            <a:schemeClr val="accent1"/>
+          </a:effectRef>
+          <a:fontRef idx="minor">
+            <a:schemeClr val="lt1"/>
+          </a:fontRef>
+        </p:style>
+        <p:txBody>
+          <a:bodyPr rtlCol="0" anchor="ctr"/>
+          <a:lstStyle/>
+          <a:p>
+            <a:pPr algn="ctr"/>
+          </a:p>
+        </p:txBody>
+      </p:sp>
+      <p:sp>
+        <p:nvSpPr>
+          <p:cNvPr id="53" name="logo_text"/>
+          <p:cNvSpPr txBox="1"/>
+          <p:nvPr/>
+        </p:nvSpPr>
+        <p:spPr>
+          <a:xfrm>
+            <a:off x="10843686" y="201168"/>
+            <a:ext cx="1134953" cy="241401"/>
           </a:xfrm>
           <a:prstGeom prst="rect">
             <a:avLst/>
@@ -28362,48 +29573,84 @@
           </a:bodyPr>
           <a:lstStyle/>
           <a:p>
-            <a:pPr algn="ctr"/>
-            <a:r>
-              <a:rPr b="1" sz="1400">
+            <a:pPr algn="l"/>
+            <a:r>
+              <a:rPr sz="750" b="1">
+                <a:solidFill>
+                  <a:srgbClr val="EEF7F7"/>
+                </a:solidFill>
+                <a:latin typeface="Helvetica Neue"/>
+              </a:rPr>
+              <a:t>VELA SYNC</a:t>
+            </a:r>
+          </a:p>
+        </p:txBody>
+      </p:sp>
+      <p:sp>
+        <p:nvSpPr>
+          <p:cNvPr id="54" name="logo_subtext"/>
+          <p:cNvSpPr txBox="1"/>
+          <p:nvPr/>
+        </p:nvSpPr>
+        <p:spPr>
+          <a:xfrm>
+            <a:off x="10843686" y="405993"/>
+            <a:ext cx="1134953" cy="175564"/>
+          </a:xfrm>
+          <a:prstGeom prst="rect">
+            <a:avLst/>
+          </a:prstGeom>
+          <a:noFill/>
+        </p:spPr>
+        <p:txBody>
+          <a:bodyPr wrap="none">
+            <a:spAutoFit/>
+          </a:bodyPr>
+          <a:lstStyle/>
+          <a:p>
+            <a:pPr algn="l"/>
+            <a:r>
+              <a:rPr sz="500">
+                <a:solidFill>
+                  <a:srgbClr val="3AAEAE"/>
+                </a:solidFill>
+                <a:latin typeface="Helvetica Neue"/>
+              </a:rPr>
+              <a:t>velasync.co.uk</a:t>
+            </a:r>
+          </a:p>
+        </p:txBody>
+      </p:sp>
+      <p:sp>
+        <p:nvSpPr>
+          <p:cNvPr id="56" name="logo_icon"/>
+          <p:cNvSpPr txBox="1"/>
+          <p:nvPr/>
+        </p:nvSpPr>
+        <p:spPr>
+          <a:xfrm>
+            <a:off x="10441862" y="216164"/>
+            <a:ext cx="283537" cy="298460"/>
+          </a:xfrm>
+          <a:prstGeom prst="rect">
+            <a:avLst/>
+          </a:prstGeom>
+          <a:noFill/>
+        </p:spPr>
+        <p:txBody>
+          <a:bodyPr wrap="none">
+            <a:spAutoFit/>
+          </a:bodyPr>
+          <a:lstStyle/>
+          <a:p>
+            <a:pPr algn="ctr"/>
+            <a:r>
+              <a:rPr sz="1527">
                 <a:solidFill>
                   <a:srgbClr val="FFFFFF"/>
                 </a:solidFill>
               </a:rPr>
-              <a:t>VS</a:t>
-            </a:r>
-          </a:p>
-        </p:txBody>
-      </p:sp>
-      <p:sp>
-        <p:nvSpPr>
-          <p:cNvPr id="50" name="TextBox 49"/>
-          <p:cNvSpPr txBox="1"/>
-          <p:nvPr/>
-        </p:nvSpPr>
-        <p:spPr>
-          <a:xfrm>
-            <a:off x="10360152" y="320040"/>
-            <a:ext cx="1005840" cy="274320"/>
-          </a:xfrm>
-          <a:prstGeom prst="rect">
-            <a:avLst/>
-          </a:prstGeom>
-          <a:noFill/>
-        </p:spPr>
-        <p:txBody>
-          <a:bodyPr wrap="none">
-            <a:spAutoFit/>
-          </a:bodyPr>
-          <a:lstStyle/>
-          <a:p>
-            <a:pPr algn="r"/>
-            <a:r>
-              <a:rPr b="1" sz="800">
-                <a:solidFill>
-                  <a:srgbClr val="EEF7F7"/>
-                </a:solidFill>
-              </a:rPr>
-              <a:t>VELA SYNC</a:t>
+              <a:t>⛵</a:t>
             </a:r>
           </a:p>
         </p:txBody>

</xml_diff>